<commit_message>
Robustesse runtime, evaluation multi-run et synthese soutenance
- rag.py : retry exponentiel sur l'appel chat (absorbe les HTTP 429
  Mistral en runtime CLI/Streamlit).
- evaluation.py : mode multi-run (evaluate_multi) avec moyenne +/-
  ecart-type, agregat par question (variance du juge), summarize() ;
  imports LLM rendus paresseux pour testabilite.
- 05_evaluate.py : option --runs N + detail par question en multi-run.
- Synthese soutenance (docs/synthese_soutenance.md + .docx) : antiseche
  a jour avec reponses aux 6 questions de la grille.
- Docs regenerees : journal (J18-J19), rapport, lessons, README, slides.

Metriques robustes (3 runs) : hit_rate 100%, cosine 0.897+/-0.003,
juge 4.22+/-0.07/5.

Co-Authored-By: Claude Opus 4.7 <noreply@anthropic.com>
</commit_message>
<xml_diff>
--- a/docs/presentation.pptx
+++ b/docs/presentation.pptx
@@ -4014,7 +4014,7 @@
                 </a:solidFill>
                 <a:latin typeface="Calibri"/>
               </a:rPr>
-              <a:t>source attendue</a:t>
+              <a:t>deterministe</a:t>
             </a:r>
           </a:p>
           <a:p>
@@ -4026,7 +4026,7 @@
                 </a:solidFill>
                 <a:latin typeface="Calibri"/>
               </a:rPr>
-              <a:t>dans le top-k</a:t>
+              <a:t>(retriever)</a:t>
             </a:r>
           </a:p>
         </p:txBody>
@@ -4135,7 +4135,7 @@
                   <a:srgbClr val="4338CA"/>
                 </a:solidFill>
               </a:rPr>
-              <a:t>0,890</a:t>
+              <a:t>0,893</a:t>
             </a:r>
           </a:p>
         </p:txBody>
@@ -4170,7 +4170,7 @@
                 </a:solidFill>
                 <a:latin typeface="Calibri"/>
               </a:rPr>
-              <a:t>cosine moyenne</a:t>
+              <a:t>cosine moyen</a:t>
             </a:r>
           </a:p>
           <a:p>
@@ -4182,7 +4182,7 @@
                 </a:solidFill>
                 <a:latin typeface="Calibri"/>
               </a:rPr>
-              <a:t>reponse vs annotee</a:t>
+              <a:t>+/- 0,003 (stable)</a:t>
             </a:r>
           </a:p>
           <a:p>
@@ -4194,7 +4194,7 @@
                 </a:solidFill>
                 <a:latin typeface="Calibri"/>
               </a:rPr>
-              <a:t>(mistral-embed)</a:t>
+              <a:t>sur plusieurs runs</a:t>
             </a:r>
           </a:p>
         </p:txBody>
@@ -4350,7 +4350,7 @@
                 </a:solidFill>
                 <a:latin typeface="Calibri"/>
               </a:rPr>
-              <a:t>mistral-small (T=0)</a:t>
+              <a:t>+/- 0,18 (variance)</a:t>
             </a:r>
           </a:p>
           <a:p>
@@ -4362,7 +4362,7 @@
                 </a:solidFill>
                 <a:latin typeface="Calibri"/>
               </a:rPr>
-              <a:t>qualite percue</a:t>
+              <a:t>moyenne multi-run</a:t>
             </a:r>
           </a:p>
         </p:txBody>
@@ -4417,7 +4417,7 @@
                 </a:solidFill>
                 <a:latin typeface="Calibri"/>
               </a:rPr>
-              <a:t>tuning + filtre anti-bruit</a:t>
+              <a:t>juge non deterministe</a:t>
             </a:r>
           </a:p>
         </p:txBody>

</xml_diff>

<commit_message>
Documente le non-choix de RAGAS + aide-memoire Docker
- RAGAS : justification du non-usage au POC, inscrite dans tous les
  documents (journal J21, rapport 6.2, synthese, lessons 18, README,
  deroule, slide eval). Verification PyPI : ragas depend de openai +
  langchain_openai + datasets -> incoherent avec stack 100% Mistral,
  hors perimetre consigne. Garde en reco v1.
- Aide-memoire commandes Docker + tableau de persistance (bind mount)
  ajoutes au README, rapport (annexe), deroule (etape Docker) et
  synthese (section demo live).
- Docs et slides regeneres.

Co-Authored-By: Claude Opus 4.7 <noreply@anthropic.com>
</commit_message>
<xml_diff>
--- a/docs/presentation.pptx
+++ b/docs/presentation.pptx
@@ -4430,8 +4430,8 @@
         </p:nvSpPr>
         <p:spPr>
           <a:xfrm>
-            <a:off x="548640" y="5943600"/>
-            <a:ext cx="11155680" cy="365760"/>
+            <a:off x="548640" y="5623560"/>
+            <a:ext cx="11155680" cy="320040"/>
           </a:xfrm>
           <a:prstGeom prst="rect">
             <a:avLst/>
@@ -4452,14 +4452,49 @@
                 </a:solidFill>
                 <a:latin typeface="Calibri"/>
               </a:rPr>
-              <a:t>Sortie : data/eval/results.csv  +  resume console   -   scripts/05_evaluate.py</a:t>
+              <a:t>Critere consigne : reponse = meme sens + memes infos que l'annotation -&gt; couvert par cosine + juge</a:t>
+            </a:r>
+          </a:p>
+        </p:txBody>
+      </p:sp>
+      <p:sp>
+        <p:nvSpPr>
+          <p:cNvPr id="15" name="TextBox 14"/>
+          <p:cNvSpPr txBox="1"/>
+          <p:nvPr/>
+        </p:nvSpPr>
+        <p:spPr>
+          <a:xfrm>
+            <a:off x="548640" y="5989320"/>
+            <a:ext cx="11155680" cy="320040"/>
+          </a:xfrm>
+          <a:prstGeom prst="rect">
+            <a:avLst/>
+          </a:prstGeom>
+          <a:noFill/>
+        </p:spPr>
+        <p:txBody>
+          <a:bodyPr wrap="square" lIns="36576" rIns="36576" tIns="18288" bIns="18288" anchor="t">
+            <a:spAutoFit/>
+          </a:bodyPr>
+          <a:lstStyle/>
+          <a:p>
+            <a:pPr algn="ctr"/>
+            <a:r>
+              <a:rPr sz="1100" b="0" i="1">
+                <a:solidFill>
+                  <a:srgbClr val="C2770E"/>
+                </a:solidFill>
+                <a:latin typeface="Calibri"/>
+              </a:rPr>
+              <a:t>RAGAS ecarte au POC (depend de openai + langchain_openai, hors stack Mistral) -&gt; garde en reco v1</a:t>
             </a:r>
           </a:p>
         </p:txBody>
       </p:sp>
       <p:cxnSp>
         <p:nvCxnSpPr>
-          <p:cNvPr id="15" name="Connector 14"/>
+          <p:cNvPr id="16" name="Connector 15"/>
           <p:cNvCxnSpPr/>
           <p:nvPr/>
         </p:nvCxnSpPr>
@@ -4494,7 +4529,7 @@
       </p:cxnSp>
       <p:sp>
         <p:nvSpPr>
-          <p:cNvPr id="16" name="TextBox 15"/>
+          <p:cNvPr id="17" name="TextBox 16"/>
           <p:cNvSpPr txBox="1"/>
           <p:nvPr/>
         </p:nvSpPr>
@@ -4529,7 +4564,7 @@
       </p:sp>
       <p:sp>
         <p:nvSpPr>
-          <p:cNvPr id="17" name="TextBox 16"/>
+          <p:cNvPr id="18" name="TextBox 17"/>
           <p:cNvSpPr txBox="1"/>
           <p:nvPr/>
         </p:nvSpPr>

</xml_diff>